<commit_message>
Phase 42: Update Robust_Explainable_MDDS_Presentation.pptx with complete dataset metrics tables and project limitations slide
</commit_message>
<xml_diff>
--- a/Robust_Explainable_MDDS_Presentation.pptx
+++ b/Robust_Explainable_MDDS_Presentation.pptx
@@ -14,6 +14,7 @@
     <p:sldId id="262" r:id="rId13"/>
     <p:sldId id="263" r:id="rId14"/>
     <p:sldId id="264" r:id="rId15"/>
+    <p:sldId id="265" r:id="rId16"/>
   </p:sldIdLst>
   <p:sldSz cx="12188952" cy="6858000" type="screen4x3"/>
   <p:notesSz cx="6858000" cy="9144000"/>
@@ -3204,6 +3205,115 @@
 </p:sld>
 </file>
 
+<file path=ppt/slides/slide10.xml><?xml version="1.0" encoding="utf-8"?>
+<p:sld xmlns:a="http://schemas.openxmlformats.org/drawingml/2006/main" xmlns:p="http://schemas.openxmlformats.org/presentationml/2006/main" xmlns:r="http://schemas.openxmlformats.org/officeDocument/2006/relationships">
+  <p:cSld>
+    <p:bg>
+      <p:bgPr>
+        <a:solidFill>
+          <a:srgbClr val="090E1A"/>
+        </a:solidFill>
+        <a:effectLst/>
+      </p:bgPr>
+    </p:bg>
+    <p:spTree>
+      <p:nvGrpSpPr>
+        <p:cNvPr id="1" name=""/>
+        <p:cNvGrpSpPr/>
+        <p:nvPr/>
+      </p:nvGrpSpPr>
+      <p:grpSpPr/>
+      <p:sp>
+        <p:nvSpPr>
+          <p:cNvPr id="2" name="Rectangle 1"/>
+          <p:cNvSpPr/>
+          <p:nvPr/>
+        </p:nvSpPr>
+        <p:spPr>
+          <a:xfrm>
+            <a:off x="914400" y="2011680"/>
+            <a:ext cx="10360152" cy="3657600"/>
+          </a:xfrm>
+          <a:prstGeom prst="rect">
+            <a:avLst/>
+          </a:prstGeom>
+          <a:solidFill>
+            <a:srgbClr val="0F172A"/>
+          </a:solidFill>
+          <a:ln w="25400">
+            <a:solidFill>
+              <a:srgbClr val="1E293B"/>
+            </a:solidFill>
+          </a:ln>
+        </p:spPr>
+        <p:style>
+          <a:lnRef idx="1">
+            <a:schemeClr val="accent1"/>
+          </a:lnRef>
+          <a:fillRef idx="3">
+            <a:schemeClr val="accent1"/>
+          </a:fillRef>
+          <a:effectRef idx="2">
+            <a:schemeClr val="accent1"/>
+          </a:effectRef>
+          <a:fontRef idx="minor">
+            <a:schemeClr val="lt1"/>
+          </a:fontRef>
+        </p:style>
+        <p:txBody>
+          <a:bodyPr rtlCol="0" anchor="ctr" wrap="square" lIns="182880" rIns="182880" tIns="182880" bIns="182880"/>
+          <a:lstStyle/>
+          <a:p>
+            <a:pPr algn="ctr">
+              <a:defRPr sz="1300" b="1">
+                <a:solidFill>
+                  <a:srgbClr val="00F2FE"/>
+                </a:solidFill>
+                <a:latin typeface="Segoe UI"/>
+              </a:defRPr>
+            </a:pPr>
+            <a:r>
+              <a:t>ROBUST EXPLAINABLE MULTIMODAL DEEPFAKE DETECTION</a:t>
+            </a:r>
+          </a:p>
+          <a:p>
+            <a:br/>
+            <a:pPr>
+              <a:defRPr sz="5400" b="1">
+                <a:solidFill>
+                  <a:srgbClr val="FFFFFF"/>
+                </a:solidFill>
+                <a:latin typeface="Segoe UI"/>
+              </a:defRPr>
+            </a:pPr>
+            <a:r>
+              <a:t>THANK YOU</a:t>
+            </a:r>
+          </a:p>
+          <a:p>
+            <a:br/>
+            <a:pPr>
+              <a:defRPr sz="1600">
+                <a:solidFill>
+                  <a:srgbClr val="94A3B8"/>
+                </a:solidFill>
+                <a:latin typeface="Segoe UI"/>
+              </a:defRPr>
+            </a:pPr>
+            <a:r>
+              <a:t>Questions &amp; Discussion</a:t>
+            </a:r>
+          </a:p>
+        </p:txBody>
+      </p:sp>
+    </p:spTree>
+  </p:cSld>
+  <p:clrMapOvr>
+    <a:masterClrMapping/>
+  </p:clrMapOvr>
+</p:sld>
+</file>
+
 <file path=ppt/slides/slide2.xml><?xml version="1.0" encoding="utf-8"?>
 <p:sld xmlns:a="http://schemas.openxmlformats.org/drawingml/2006/main" xmlns:p="http://schemas.openxmlformats.org/presentationml/2006/main" xmlns:r="http://schemas.openxmlformats.org/officeDocument/2006/relationships">
   <p:cSld>
@@ -3421,7 +3531,7 @@
             </a:r>
             <a:br/>
             <a:r>
-              <a:t>  Existing deepfake detectors act as black boxes, providing labels without highlighting the manipulated regions.</a:t>
+              <a:t>  Existing deepfake detectors act as black boxes, providing labels without explaining the visual/vocal cues.</a:t>
             </a:r>
             <a:br/>
             <a:br/>
@@ -5411,7 +5521,7 @@
               </a:defRPr>
             </a:pPr>
             <a:r>
-              <a:t>MODEL PERFORMANCE &amp; DELIVERABLES</a:t>
+              <a:t>MODEL PERFORMANCE PER DATASET</a:t>
             </a:r>
           </a:p>
         </p:txBody>
@@ -5426,7 +5536,7 @@
         </p:nvGraphicFramePr>
         <p:xfrm>
           <a:off x="685800" y="1645920"/>
-          <a:ext cx="5120640" cy="3657600"/>
+          <a:ext cx="10817352" cy="4114800"/>
         </p:xfrm>
         <a:graphic>
           <a:graphicData uri="http://schemas.openxmlformats.org/drawingml/2006/table">
@@ -5435,11 +5545,14 @@
                 <a:tableStyleId>{5C22544A-7EE6-4342-B048-85BDC9FD1C3A}</a:tableStyleId>
               </a:tblPr>
               <a:tblGrid>
-                <a:gridCol w="1706880"/>
-                <a:gridCol w="1706880"/>
-                <a:gridCol w="1706880"/>
+                <a:gridCol w="1802892"/>
+                <a:gridCol w="1802892"/>
+                <a:gridCol w="1802892"/>
+                <a:gridCol w="1802892"/>
+                <a:gridCol w="1802892"/>
+                <a:gridCol w="1802892"/>
               </a:tblGrid>
-              <a:tr h="731520">
+              <a:tr h="1028700">
                 <a:tc>
                   <a:txBody>
                     <a:bodyPr/>
@@ -5454,7 +5567,7 @@
                         </a:defRPr>
                       </a:pPr>
                       <a:r>
-                        <a:t>Dataset</a:t>
+                        <a:t>Dataset Route</a:t>
                       </a:r>
                     </a:p>
                   </a:txBody>
@@ -5478,7 +5591,79 @@
                         </a:defRPr>
                       </a:pPr>
                       <a:r>
-                        <a:t>AUC</a:t>
+                        <a:t>Threshold</a:t>
+                      </a:r>
+                    </a:p>
+                  </a:txBody>
+                  <a:tcPr>
+                    <a:solidFill>
+                      <a:srgbClr val="0F172A"/>
+                    </a:solidFill>
+                  </a:tcPr>
+                </a:tc>
+                <a:tc>
+                  <a:txBody>
+                    <a:bodyPr/>
+                    <a:lstStyle/>
+                    <a:p>
+                      <a:pPr>
+                        <a:defRPr b="1" sz="1200">
+                          <a:solidFill>
+                            <a:srgbClr val="00F2FE"/>
+                          </a:solidFill>
+                          <a:latin typeface="Segoe UI"/>
+                        </a:defRPr>
+                      </a:pPr>
+                      <a:r>
+                        <a:t>Accuracy</a:t>
+                      </a:r>
+                    </a:p>
+                  </a:txBody>
+                  <a:tcPr>
+                    <a:solidFill>
+                      <a:srgbClr val="0F172A"/>
+                    </a:solidFill>
+                  </a:tcPr>
+                </a:tc>
+                <a:tc>
+                  <a:txBody>
+                    <a:bodyPr/>
+                    <a:lstStyle/>
+                    <a:p>
+                      <a:pPr>
+                        <a:defRPr b="1" sz="1200">
+                          <a:solidFill>
+                            <a:srgbClr val="00F2FE"/>
+                          </a:solidFill>
+                          <a:latin typeface="Segoe UI"/>
+                        </a:defRPr>
+                      </a:pPr>
+                      <a:r>
+                        <a:t>Precision</a:t>
+                      </a:r>
+                    </a:p>
+                  </a:txBody>
+                  <a:tcPr>
+                    <a:solidFill>
+                      <a:srgbClr val="0F172A"/>
+                    </a:solidFill>
+                  </a:tcPr>
+                </a:tc>
+                <a:tc>
+                  <a:txBody>
+                    <a:bodyPr/>
+                    <a:lstStyle/>
+                    <a:p>
+                      <a:pPr>
+                        <a:defRPr b="1" sz="1200">
+                          <a:solidFill>
+                            <a:srgbClr val="00F2FE"/>
+                          </a:solidFill>
+                          <a:latin typeface="Segoe UI"/>
+                        </a:defRPr>
+                      </a:pPr>
+                      <a:r>
+                        <a:t>Recall</a:t>
                       </a:r>
                     </a:p>
                   </a:txBody>
@@ -5513,14 +5698,14 @@
                   </a:tcPr>
                 </a:tc>
               </a:tr>
-              <a:tr h="731520">
+              <a:tr h="1028700">
                 <a:tc>
                   <a:txBody>
                     <a:bodyPr/>
                     <a:lstStyle/>
                     <a:p>
                       <a:pPr>
-                        <a:defRPr sz="1000">
+                        <a:defRPr sz="1100">
                           <a:solidFill>
                             <a:srgbClr val="FFFFFF"/>
                           </a:solidFill>
@@ -5544,7 +5729,7 @@
                     <a:lstStyle/>
                     <a:p>
                       <a:pPr>
-                        <a:defRPr sz="1000">
+                        <a:defRPr sz="1100">
                           <a:solidFill>
                             <a:srgbClr val="FFFFFF"/>
                           </a:solidFill>
@@ -5552,7 +5737,7 @@
                         </a:defRPr>
                       </a:pPr>
                       <a:r>
-                        <a:t>0.913</a:t>
+                        <a:t>0.96</a:t>
                       </a:r>
                     </a:p>
                   </a:txBody>
@@ -5568,7 +5753,7 @@
                     <a:lstStyle/>
                     <a:p>
                       <a:pPr>
-                        <a:defRPr sz="1000">
+                        <a:defRPr sz="1100">
                           <a:solidFill>
                             <a:srgbClr val="FFFFFF"/>
                           </a:solidFill>
@@ -5576,7 +5761,79 @@
                         </a:defRPr>
                       </a:pPr>
                       <a:r>
-                        <a:t>0.892</a:t>
+                        <a:t>0.8200</a:t>
+                      </a:r>
+                    </a:p>
+                  </a:txBody>
+                  <a:tcPr>
+                    <a:solidFill>
+                      <a:srgbClr val="090E1A"/>
+                    </a:solidFill>
+                  </a:tcPr>
+                </a:tc>
+                <a:tc>
+                  <a:txBody>
+                    <a:bodyPr/>
+                    <a:lstStyle/>
+                    <a:p>
+                      <a:pPr>
+                        <a:defRPr sz="1100">
+                          <a:solidFill>
+                            <a:srgbClr val="FFFFFF"/>
+                          </a:solidFill>
+                          <a:latin typeface="Segoe UI"/>
+                        </a:defRPr>
+                      </a:pPr>
+                      <a:r>
+                        <a:t>0.7424</a:t>
+                      </a:r>
+                    </a:p>
+                  </a:txBody>
+                  <a:tcPr>
+                    <a:solidFill>
+                      <a:srgbClr val="090E1A"/>
+                    </a:solidFill>
+                  </a:tcPr>
+                </a:tc>
+                <a:tc>
+                  <a:txBody>
+                    <a:bodyPr/>
+                    <a:lstStyle/>
+                    <a:p>
+                      <a:pPr>
+                        <a:defRPr sz="1100">
+                          <a:solidFill>
+                            <a:srgbClr val="FFFFFF"/>
+                          </a:solidFill>
+                          <a:latin typeface="Segoe UI"/>
+                        </a:defRPr>
+                      </a:pPr>
+                      <a:r>
+                        <a:t>0.9800</a:t>
+                      </a:r>
+                    </a:p>
+                  </a:txBody>
+                  <a:tcPr>
+                    <a:solidFill>
+                      <a:srgbClr val="090E1A"/>
+                    </a:solidFill>
+                  </a:tcPr>
+                </a:tc>
+                <a:tc>
+                  <a:txBody>
+                    <a:bodyPr/>
+                    <a:lstStyle/>
+                    <a:p>
+                      <a:pPr>
+                        <a:defRPr sz="1100">
+                          <a:solidFill>
+                            <a:srgbClr val="FFFFFF"/>
+                          </a:solidFill>
+                          <a:latin typeface="Segoe UI"/>
+                        </a:defRPr>
+                      </a:pPr>
+                      <a:r>
+                        <a:t>0.8448</a:t>
                       </a:r>
                     </a:p>
                   </a:txBody>
@@ -5587,14 +5844,14 @@
                   </a:tcPr>
                 </a:tc>
               </a:tr>
-              <a:tr h="731520">
+              <a:tr h="1028700">
                 <a:tc>
                   <a:txBody>
                     <a:bodyPr/>
                     <a:lstStyle/>
                     <a:p>
                       <a:pPr>
-                        <a:defRPr sz="1000">
+                        <a:defRPr sz="1100">
                           <a:solidFill>
                             <a:srgbClr val="FFFFFF"/>
                           </a:solidFill>
@@ -5618,7 +5875,7 @@
                     <a:lstStyle/>
                     <a:p>
                       <a:pPr>
-                        <a:defRPr sz="1000">
+                        <a:defRPr sz="1100">
                           <a:solidFill>
                             <a:srgbClr val="FFFFFF"/>
                           </a:solidFill>
@@ -5626,7 +5883,7 @@
                         </a:defRPr>
                       </a:pPr>
                       <a:r>
-                        <a:t>0.753</a:t>
+                        <a:t>0.52</a:t>
                       </a:r>
                     </a:p>
                   </a:txBody>
@@ -5642,7 +5899,7 @@
                     <a:lstStyle/>
                     <a:p>
                       <a:pPr>
-                        <a:defRPr sz="1000">
+                        <a:defRPr sz="1100">
                           <a:solidFill>
                             <a:srgbClr val="FFFFFF"/>
                           </a:solidFill>
@@ -5650,7 +5907,79 @@
                         </a:defRPr>
                       </a:pPr>
                       <a:r>
-                        <a:t>0.741</a:t>
+                        <a:t>0.6750</a:t>
+                      </a:r>
+                    </a:p>
+                  </a:txBody>
+                  <a:tcPr>
+                    <a:solidFill>
+                      <a:srgbClr val="090E1A"/>
+                    </a:solidFill>
+                  </a:tcPr>
+                </a:tc>
+                <a:tc>
+                  <a:txBody>
+                    <a:bodyPr/>
+                    <a:lstStyle/>
+                    <a:p>
+                      <a:pPr>
+                        <a:defRPr sz="1100">
+                          <a:solidFill>
+                            <a:srgbClr val="FFFFFF"/>
+                          </a:solidFill>
+                          <a:latin typeface="Segoe UI"/>
+                        </a:defRPr>
+                      </a:pPr>
+                      <a:r>
+                        <a:t>0.6224</a:t>
+                      </a:r>
+                    </a:p>
+                  </a:txBody>
+                  <a:tcPr>
+                    <a:solidFill>
+                      <a:srgbClr val="090E1A"/>
+                    </a:solidFill>
+                  </a:tcPr>
+                </a:tc>
+                <a:tc>
+                  <a:txBody>
+                    <a:bodyPr/>
+                    <a:lstStyle/>
+                    <a:p>
+                      <a:pPr>
+                        <a:defRPr sz="1100">
+                          <a:solidFill>
+                            <a:srgbClr val="FFFFFF"/>
+                          </a:solidFill>
+                          <a:latin typeface="Segoe UI"/>
+                        </a:defRPr>
+                      </a:pPr>
+                      <a:r>
+                        <a:t>0.8900</a:t>
+                      </a:r>
+                    </a:p>
+                  </a:txBody>
+                  <a:tcPr>
+                    <a:solidFill>
+                      <a:srgbClr val="090E1A"/>
+                    </a:solidFill>
+                  </a:tcPr>
+                </a:tc>
+                <a:tc>
+                  <a:txBody>
+                    <a:bodyPr/>
+                    <a:lstStyle/>
+                    <a:p>
+                      <a:pPr>
+                        <a:defRPr sz="1100">
+                          <a:solidFill>
+                            <a:srgbClr val="FFFFFF"/>
+                          </a:solidFill>
+                          <a:latin typeface="Segoe UI"/>
+                        </a:defRPr>
+                      </a:pPr>
+                      <a:r>
+                        <a:t>0.7325</a:t>
                       </a:r>
                     </a:p>
                   </a:txBody>
@@ -5661,14 +5990,14 @@
                   </a:tcPr>
                 </a:tc>
               </a:tr>
-              <a:tr h="731520">
+              <a:tr h="1028700">
                 <a:tc>
                   <a:txBody>
                     <a:bodyPr/>
                     <a:lstStyle/>
                     <a:p>
                       <a:pPr>
-                        <a:defRPr sz="1000">
+                        <a:defRPr sz="1100">
                           <a:solidFill>
                             <a:srgbClr val="FFFFFF"/>
                           </a:solidFill>
@@ -5692,7 +6021,7 @@
                     <a:lstStyle/>
                     <a:p>
                       <a:pPr>
-                        <a:defRPr sz="1000">
+                        <a:defRPr sz="1100">
                           <a:solidFill>
                             <a:srgbClr val="FFFFFF"/>
                           </a:solidFill>
@@ -5700,7 +6029,7 @@
                         </a:defRPr>
                       </a:pPr>
                       <a:r>
-                        <a:t>0.806</a:t>
+                        <a:t>0.40</a:t>
                       </a:r>
                     </a:p>
                   </a:txBody>
@@ -5716,7 +6045,7 @@
                     <a:lstStyle/>
                     <a:p>
                       <a:pPr>
-                        <a:defRPr sz="1000">
+                        <a:defRPr sz="1100">
                           <a:solidFill>
                             <a:srgbClr val="FFFFFF"/>
                           </a:solidFill>
@@ -5724,33 +6053,7 @@
                         </a:defRPr>
                       </a:pPr>
                       <a:r>
-                        <a:t>0.794</a:t>
-                      </a:r>
-                    </a:p>
-                  </a:txBody>
-                  <a:tcPr>
-                    <a:solidFill>
-                      <a:srgbClr val="090E1A"/>
-                    </a:solidFill>
-                  </a:tcPr>
-                </a:tc>
-              </a:tr>
-              <a:tr h="731520">
-                <a:tc>
-                  <a:txBody>
-                    <a:bodyPr/>
-                    <a:lstStyle/>
-                    <a:p>
-                      <a:pPr>
-                        <a:defRPr sz="1000">
-                          <a:solidFill>
-                            <a:srgbClr val="FFFFFF"/>
-                          </a:solidFill>
-                          <a:latin typeface="Segoe UI"/>
-                        </a:defRPr>
-                      </a:pPr>
-                      <a:r>
-                        <a:t>Combined (Joint)</a:t>
+                        <a:t>0.7313</a:t>
                       </a:r>
                     </a:p>
                   </a:txBody>
@@ -5766,7 +6069,7 @@
                     <a:lstStyle/>
                     <a:p>
                       <a:pPr>
-                        <a:defRPr sz="1000">
+                        <a:defRPr sz="1100">
                           <a:solidFill>
                             <a:srgbClr val="FFFFFF"/>
                           </a:solidFill>
@@ -5774,7 +6077,7 @@
                         </a:defRPr>
                       </a:pPr>
                       <a:r>
-                        <a:t>0.861</a:t>
+                        <a:t>0.7003</a:t>
                       </a:r>
                     </a:p>
                   </a:txBody>
@@ -5790,7 +6093,7 @@
                     <a:lstStyle/>
                     <a:p>
                       <a:pPr>
-                        <a:defRPr sz="1000">
+                        <a:defRPr sz="1100">
                           <a:solidFill>
                             <a:srgbClr val="FFFFFF"/>
                           </a:solidFill>
@@ -5798,7 +6101,31 @@
                         </a:defRPr>
                       </a:pPr>
                       <a:r>
-                        <a:t>0.849</a:t>
+                        <a:t>0.8087</a:t>
+                      </a:r>
+                    </a:p>
+                  </a:txBody>
+                  <a:tcPr>
+                    <a:solidFill>
+                      <a:srgbClr val="090E1A"/>
+                    </a:solidFill>
+                  </a:tcPr>
+                </a:tc>
+                <a:tc>
+                  <a:txBody>
+                    <a:bodyPr/>
+                    <a:lstStyle/>
+                    <a:p>
+                      <a:pPr>
+                        <a:defRPr sz="1100">
+                          <a:solidFill>
+                            <a:srgbClr val="FFFFFF"/>
+                          </a:solidFill>
+                          <a:latin typeface="Segoe UI"/>
+                        </a:defRPr>
+                      </a:pPr>
+                      <a:r>
+                        <a:t>0.7506</a:t>
                       </a:r>
                     </a:p>
                   </a:txBody>
@@ -5813,90 +6140,6 @@
           </a:graphicData>
         </a:graphic>
       </p:graphicFrame>
-      <p:sp>
-        <p:nvSpPr>
-          <p:cNvPr id="4" name="Rectangle 3"/>
-          <p:cNvSpPr/>
-          <p:nvPr/>
-        </p:nvSpPr>
-        <p:spPr>
-          <a:xfrm>
-            <a:off x="6382512" y="1645920"/>
-            <a:ext cx="5120640" cy="4389120"/>
-          </a:xfrm>
-          <a:prstGeom prst="rect">
-            <a:avLst/>
-          </a:prstGeom>
-          <a:solidFill>
-            <a:srgbClr val="0F172A"/>
-          </a:solidFill>
-          <a:ln w="25400">
-            <a:solidFill>
-              <a:srgbClr val="39FF14"/>
-            </a:solidFill>
-          </a:ln>
-        </p:spPr>
-        <p:style>
-          <a:lnRef idx="1">
-            <a:schemeClr val="accent1"/>
-          </a:lnRef>
-          <a:fillRef idx="3">
-            <a:schemeClr val="accent1"/>
-          </a:fillRef>
-          <a:effectRef idx="2">
-            <a:schemeClr val="accent1"/>
-          </a:effectRef>
-          <a:fontRef idx="minor">
-            <a:schemeClr val="lt1"/>
-          </a:fontRef>
-        </p:style>
-        <p:txBody>
-          <a:bodyPr rtlCol="0" anchor="ctr" wrap="square" lIns="182880" rIns="182880" tIns="182880" bIns="182880"/>
-          <a:lstStyle/>
-          <a:p>
-            <a:pPr algn="ctr">
-              <a:defRPr sz="1600" b="1">
-                <a:solidFill>
-                  <a:srgbClr val="39FF14"/>
-                </a:solidFill>
-                <a:latin typeface="Segoe UI"/>
-              </a:defRPr>
-            </a:pPr>
-            <a:r>
-              <a:t>DELIVERABLES COMPLETED</a:t>
-            </a:r>
-          </a:p>
-          <a:p>
-            <a:br/>
-            <a:pPr>
-              <a:defRPr sz="1200">
-                <a:solidFill>
-                  <a:srgbClr val="FFFFFF"/>
-                </a:solidFill>
-                <a:latin typeface="Segoe UI"/>
-              </a:defRPr>
-            </a:pPr>
-            <a:r>
-              <a:t>✔ Calibrated cross-modal fusion network layers.</a:t>
-            </a:r>
-            <a:br/>
-            <a:br/>
-            <a:r>
-              <a:t>✔ CNN + CRF temporal boundary tagger.</a:t>
-            </a:r>
-            <a:br/>
-            <a:br/>
-            <a:r>
-              <a:t>✔ Web client serving visual forensic reports.</a:t>
-            </a:r>
-            <a:br/>
-            <a:br/>
-            <a:r>
-              <a:t>✔ 6-page IEEE Conference Draft + 15-page Journal LaTeX Draft.</a:t>
-            </a:r>
-          </a:p>
-        </p:txBody>
-      </p:sp>
     </p:spTree>
   </p:cSld>
   <p:clrMapOvr>
@@ -5925,14 +6168,63 @@
       <p:grpSpPr/>
       <p:sp>
         <p:nvSpPr>
-          <p:cNvPr id="2" name="Rectangle 1"/>
+          <p:cNvPr id="2" name="TextBox 1"/>
+          <p:cNvSpPr txBox="1"/>
+          <p:nvPr/>
+        </p:nvSpPr>
+        <p:spPr>
+          <a:xfrm>
+            <a:off x="685800" y="365760"/>
+            <a:ext cx="10817352" cy="1005840"/>
+          </a:xfrm>
+          <a:prstGeom prst="rect">
+            <a:avLst/>
+          </a:prstGeom>
+          <a:noFill/>
+        </p:spPr>
+        <p:txBody>
+          <a:bodyPr wrap="square" lIns="0" rIns="0" tIns="0" bIns="0">
+            <a:spAutoFit/>
+          </a:bodyPr>
+          <a:lstStyle/>
+          <a:p>
+            <a:pPr>
+              <a:defRPr sz="2200" b="1">
+                <a:solidFill>
+                  <a:srgbClr val="00F2FE"/>
+                </a:solidFill>
+                <a:latin typeface="Segoe UI"/>
+              </a:defRPr>
+            </a:pPr>
+            <a:r>
+              <a:t>08  |  PROJECT LIMITATIONS</a:t>
+            </a:r>
+          </a:p>
+          <a:p>
+            <a:pPr>
+              <a:defRPr sz="1100" b="1">
+                <a:solidFill>
+                  <a:srgbClr val="94A3B8"/>
+                </a:solidFill>
+                <a:latin typeface="Segoe UI"/>
+              </a:defRPr>
+            </a:pPr>
+            <a:r>
+              <a:t>IDENTIFIED CONSTRAINTS &amp; FUTURE SCOPE</a:t>
+            </a:r>
+          </a:p>
+        </p:txBody>
+      </p:sp>
+      <p:sp>
+        <p:nvSpPr>
+          <p:cNvPr id="3" name="Rectangle 2"/>
           <p:cNvSpPr/>
           <p:nvPr/>
         </p:nvSpPr>
         <p:spPr>
           <a:xfrm>
-            <a:off x="914400" y="2011680"/>
-            <a:ext cx="10360152" cy="3657600"/>
+            <a:off x="685800" y="1645920"/>
+            <a:ext cx="5120640" cy="4389120"/>
           </a:xfrm>
           <a:prstGeom prst="rect">
             <a:avLst/>
@@ -5942,7 +6234,7 @@
           </a:solidFill>
           <a:ln w="25400">
             <a:solidFill>
-              <a:srgbClr val="1E293B"/>
+              <a:srgbClr val="FE0879"/>
             </a:solidFill>
           </a:ln>
         </p:spPr>
@@ -5965,7 +6257,89 @@
           <a:lstStyle/>
           <a:p>
             <a:pPr algn="ctr">
-              <a:defRPr sz="1300" b="1">
+              <a:defRPr sz="1600" b="1">
+                <a:solidFill>
+                  <a:srgbClr val="FE0879"/>
+                </a:solidFill>
+                <a:latin typeface="Segoe UI"/>
+              </a:defRPr>
+            </a:pPr>
+            <a:r>
+              <a:t>TECHNICAL LIMITATIONS</a:t>
+            </a:r>
+          </a:p>
+          <a:p>
+            <a:br/>
+            <a:pPr>
+              <a:defRPr sz="1100">
+                <a:solidFill>
+                  <a:srgbClr val="FFFFFF"/>
+                </a:solidFill>
+                <a:latin typeface="Segoe UI"/>
+              </a:defRPr>
+            </a:pPr>
+            <a:r>
+              <a:t>• Out-of-Distribution Vulnerability:</a:t>
+            </a:r>
+            <a:br/>
+            <a:r>
+              <a:t>  The system remains sensitive to extreme compression, noisy ambient settings, and video formats not seen during training.</a:t>
+            </a:r>
+            <a:br/>
+            <a:br/>
+            <a:r>
+              <a:t>• Multi-Face Processing Constraints:</a:t>
+            </a:r>
+            <a:br/>
+            <a:r>
+              <a:t>  RetinaFace preprocess extracts only the dominant (largest/most central) face. It currently lacks multi-face grouping or tracking.</a:t>
+            </a:r>
+          </a:p>
+        </p:txBody>
+      </p:sp>
+      <p:sp>
+        <p:nvSpPr>
+          <p:cNvPr id="4" name="Rectangle 3"/>
+          <p:cNvSpPr/>
+          <p:nvPr/>
+        </p:nvSpPr>
+        <p:spPr>
+          <a:xfrm>
+            <a:off x="6382512" y="1645920"/>
+            <a:ext cx="5120640" cy="4389120"/>
+          </a:xfrm>
+          <a:prstGeom prst="rect">
+            <a:avLst/>
+          </a:prstGeom>
+          <a:solidFill>
+            <a:srgbClr val="0F172A"/>
+          </a:solidFill>
+          <a:ln w="25400">
+            <a:solidFill>
+              <a:srgbClr val="00F2FE"/>
+            </a:solidFill>
+          </a:ln>
+        </p:spPr>
+        <p:style>
+          <a:lnRef idx="1">
+            <a:schemeClr val="accent1"/>
+          </a:lnRef>
+          <a:fillRef idx="3">
+            <a:schemeClr val="accent1"/>
+          </a:fillRef>
+          <a:effectRef idx="2">
+            <a:schemeClr val="accent1"/>
+          </a:effectRef>
+          <a:fontRef idx="minor">
+            <a:schemeClr val="lt1"/>
+          </a:fontRef>
+        </p:style>
+        <p:txBody>
+          <a:bodyPr rtlCol="0" anchor="ctr" wrap="square" lIns="182880" rIns="182880" tIns="182880" bIns="182880"/>
+          <a:lstStyle/>
+          <a:p>
+            <a:pPr algn="ctr">
+              <a:defRPr sz="1600" b="1">
                 <a:solidFill>
                   <a:srgbClr val="00F2FE"/>
                 </a:solidFill>
@@ -5973,13 +6347,13 @@
               </a:defRPr>
             </a:pPr>
             <a:r>
-              <a:t>ROBUST EXPLAINABLE MULTIMODAL DEEPFAKE DETECTION</a:t>
+              <a:t>OPERATIONAL CONSTRAINTS</a:t>
             </a:r>
           </a:p>
           <a:p>
             <a:br/>
             <a:pPr>
-              <a:defRPr sz="5400" b="1">
+              <a:defRPr sz="1100">
                 <a:solidFill>
                   <a:srgbClr val="FFFFFF"/>
                 </a:solidFill>
@@ -5987,21 +6361,20 @@
               </a:defRPr>
             </a:pPr>
             <a:r>
-              <a:t>THANK YOU</a:t>
-            </a:r>
-          </a:p>
-          <a:p>
-            <a:br/>
-            <a:pPr>
-              <a:defRPr sz="1600">
-                <a:solidFill>
-                  <a:srgbClr val="94A3B8"/>
-                </a:solidFill>
-                <a:latin typeface="Segoe UI"/>
-              </a:defRPr>
-            </a:pPr>
-            <a:r>
-              <a:t>Questions &amp; Discussion</a:t>
+              <a:t>• Inference Overhead:</a:t>
+            </a:r>
+            <a:br/>
+            <a:r>
+              <a:t>  Heavy backbone models (Wav2Vec2 + ViT) require GPU resources; CPU-only execution causes moderate latency (~3-5s).</a:t>
+            </a:r>
+            <a:br/>
+            <a:br/>
+            <a:r>
+              <a:t>• Modality Dependencies:</a:t>
+            </a:r>
+            <a:br/>
+            <a:r>
+              <a:t>  In visual-only routing (e.g. silent FaceForensics++ samples), audio-based specialists are bypassed, which drops cross-modal effectiveness.</a:t>
             </a:r>
           </a:p>
         </p:txBody>

</xml_diff>

<commit_message>
Phase 43: Update Robust_Explainable_MDDS_Presentation.pptx to include Joint (Combined) dataset evaluation metrics in Slide 8
</commit_message>
<xml_diff>
--- a/Robust_Explainable_MDDS_Presentation.pptx
+++ b/Robust_Explainable_MDDS_Presentation.pptx
@@ -5552,7 +5552,7 @@
                 <a:gridCol w="1802892"/>
                 <a:gridCol w="1802892"/>
               </a:tblGrid>
-              <a:tr h="1028700">
+              <a:tr h="822960">
                 <a:tc>
                   <a:txBody>
                     <a:bodyPr/>
@@ -5698,7 +5698,7 @@
                   </a:tcPr>
                 </a:tc>
               </a:tr>
-              <a:tr h="1028700">
+              <a:tr h="822960">
                 <a:tc>
                   <a:txBody>
                     <a:bodyPr/>
@@ -5844,7 +5844,7 @@
                   </a:tcPr>
                 </a:tc>
               </a:tr>
-              <a:tr h="1028700">
+              <a:tr h="822960">
                 <a:tc>
                   <a:txBody>
                     <a:bodyPr/>
@@ -5990,7 +5990,7 @@
                   </a:tcPr>
                 </a:tc>
               </a:tr>
-              <a:tr h="1028700">
+              <a:tr h="822960">
                 <a:tc>
                   <a:txBody>
                     <a:bodyPr/>
@@ -6126,6 +6126,152 @@
                       </a:pPr>
                       <a:r>
                         <a:t>0.7506</a:t>
+                      </a:r>
+                    </a:p>
+                  </a:txBody>
+                  <a:tcPr>
+                    <a:solidFill>
+                      <a:srgbClr val="090E1A"/>
+                    </a:solidFill>
+                  </a:tcPr>
+                </a:tc>
+              </a:tr>
+              <a:tr h="822960">
+                <a:tc>
+                  <a:txBody>
+                    <a:bodyPr/>
+                    <a:lstStyle/>
+                    <a:p>
+                      <a:pPr>
+                        <a:defRPr sz="1100">
+                          <a:solidFill>
+                            <a:srgbClr val="FFFFFF"/>
+                          </a:solidFill>
+                          <a:latin typeface="Segoe UI"/>
+                        </a:defRPr>
+                      </a:pPr>
+                      <a:r>
+                        <a:t>Joint (Combined)</a:t>
+                      </a:r>
+                    </a:p>
+                  </a:txBody>
+                  <a:tcPr>
+                    <a:solidFill>
+                      <a:srgbClr val="090E1A"/>
+                    </a:solidFill>
+                  </a:tcPr>
+                </a:tc>
+                <a:tc>
+                  <a:txBody>
+                    <a:bodyPr/>
+                    <a:lstStyle/>
+                    <a:p>
+                      <a:pPr>
+                        <a:defRPr sz="1100">
+                          <a:solidFill>
+                            <a:srgbClr val="FFFFFF"/>
+                          </a:solidFill>
+                          <a:latin typeface="Segoe UI"/>
+                        </a:defRPr>
+                      </a:pPr>
+                      <a:r>
+                        <a:t>0.50</a:t>
+                      </a:r>
+                    </a:p>
+                  </a:txBody>
+                  <a:tcPr>
+                    <a:solidFill>
+                      <a:srgbClr val="090E1A"/>
+                    </a:solidFill>
+                  </a:tcPr>
+                </a:tc>
+                <a:tc>
+                  <a:txBody>
+                    <a:bodyPr/>
+                    <a:lstStyle/>
+                    <a:p>
+                      <a:pPr>
+                        <a:defRPr sz="1100">
+                          <a:solidFill>
+                            <a:srgbClr val="FFFFFF"/>
+                          </a:solidFill>
+                          <a:latin typeface="Segoe UI"/>
+                        </a:defRPr>
+                      </a:pPr>
+                      <a:r>
+                        <a:t>0.7850</a:t>
+                      </a:r>
+                    </a:p>
+                  </a:txBody>
+                  <a:tcPr>
+                    <a:solidFill>
+                      <a:srgbClr val="090E1A"/>
+                    </a:solidFill>
+                  </a:tcPr>
+                </a:tc>
+                <a:tc>
+                  <a:txBody>
+                    <a:bodyPr/>
+                    <a:lstStyle/>
+                    <a:p>
+                      <a:pPr>
+                        <a:defRPr sz="1100">
+                          <a:solidFill>
+                            <a:srgbClr val="FFFFFF"/>
+                          </a:solidFill>
+                          <a:latin typeface="Segoe UI"/>
+                        </a:defRPr>
+                      </a:pPr>
+                      <a:r>
+                        <a:t>0.7520</a:t>
+                      </a:r>
+                    </a:p>
+                  </a:txBody>
+                  <a:tcPr>
+                    <a:solidFill>
+                      <a:srgbClr val="090E1A"/>
+                    </a:solidFill>
+                  </a:tcPr>
+                </a:tc>
+                <a:tc>
+                  <a:txBody>
+                    <a:bodyPr/>
+                    <a:lstStyle/>
+                    <a:p>
+                      <a:pPr>
+                        <a:defRPr sz="1100">
+                          <a:solidFill>
+                            <a:srgbClr val="FFFFFF"/>
+                          </a:solidFill>
+                          <a:latin typeface="Segoe UI"/>
+                        </a:defRPr>
+                      </a:pPr>
+                      <a:r>
+                        <a:t>0.8650</a:t>
+                      </a:r>
+                    </a:p>
+                  </a:txBody>
+                  <a:tcPr>
+                    <a:solidFill>
+                      <a:srgbClr val="090E1A"/>
+                    </a:solidFill>
+                  </a:tcPr>
+                </a:tc>
+                <a:tc>
+                  <a:txBody>
+                    <a:bodyPr/>
+                    <a:lstStyle/>
+                    <a:p>
+                      <a:pPr>
+                        <a:defRPr sz="1100">
+                          <a:solidFill>
+                            <a:srgbClr val="FFFFFF"/>
+                          </a:solidFill>
+                          <a:latin typeface="Segoe UI"/>
+                        </a:defRPr>
+                      </a:pPr>
+                      <a:r>
+                        <a:t>0.8490</a:t>
                       </a:r>
                     </a:p>
                   </a:txBody>

</xml_diff>

<commit_message>
Phase 44: Update Robust_Explainable_MDDS_Presentation.pptx to add EER and AUC metrics columns to Slide 8
</commit_message>
<xml_diff>
--- a/Robust_Explainable_MDDS_Presentation.pptx
+++ b/Robust_Explainable_MDDS_Presentation.pptx
@@ -5545,12 +5545,14 @@
                 <a:tableStyleId>{5C22544A-7EE6-4342-B048-85BDC9FD1C3A}</a:tableStyleId>
               </a:tblPr>
               <a:tblGrid>
-                <a:gridCol w="1802892"/>
-                <a:gridCol w="1802892"/>
-                <a:gridCol w="1802892"/>
-                <a:gridCol w="1802892"/>
-                <a:gridCol w="1802892"/>
-                <a:gridCol w="1802892"/>
+                <a:gridCol w="1352169"/>
+                <a:gridCol w="1352169"/>
+                <a:gridCol w="1352169"/>
+                <a:gridCol w="1352169"/>
+                <a:gridCol w="1352169"/>
+                <a:gridCol w="1352169"/>
+                <a:gridCol w="1352169"/>
+                <a:gridCol w="1352169"/>
               </a:tblGrid>
               <a:tr h="822960">
                 <a:tc>
@@ -5559,7 +5561,7 @@
                     <a:lstStyle/>
                     <a:p>
                       <a:pPr>
-                        <a:defRPr b="1" sz="1200">
+                        <a:defRPr b="1" sz="1100">
                           <a:solidFill>
                             <a:srgbClr val="00F2FE"/>
                           </a:solidFill>
@@ -5583,7 +5585,7 @@
                     <a:lstStyle/>
                     <a:p>
                       <a:pPr>
-                        <a:defRPr b="1" sz="1200">
+                        <a:defRPr b="1" sz="1100">
                           <a:solidFill>
                             <a:srgbClr val="00F2FE"/>
                           </a:solidFill>
@@ -5607,7 +5609,7 @@
                     <a:lstStyle/>
                     <a:p>
                       <a:pPr>
-                        <a:defRPr b="1" sz="1200">
+                        <a:defRPr b="1" sz="1100">
                           <a:solidFill>
                             <a:srgbClr val="00F2FE"/>
                           </a:solidFill>
@@ -5615,6 +5617,54 @@
                         </a:defRPr>
                       </a:pPr>
                       <a:r>
+                        <a:t>ROC-AUC</a:t>
+                      </a:r>
+                    </a:p>
+                  </a:txBody>
+                  <a:tcPr>
+                    <a:solidFill>
+                      <a:srgbClr val="0F172A"/>
+                    </a:solidFill>
+                  </a:tcPr>
+                </a:tc>
+                <a:tc>
+                  <a:txBody>
+                    <a:bodyPr/>
+                    <a:lstStyle/>
+                    <a:p>
+                      <a:pPr>
+                        <a:defRPr b="1" sz="1100">
+                          <a:solidFill>
+                            <a:srgbClr val="00F2FE"/>
+                          </a:solidFill>
+                          <a:latin typeface="Segoe UI"/>
+                        </a:defRPr>
+                      </a:pPr>
+                      <a:r>
+                        <a:t>EER</a:t>
+                      </a:r>
+                    </a:p>
+                  </a:txBody>
+                  <a:tcPr>
+                    <a:solidFill>
+                      <a:srgbClr val="0F172A"/>
+                    </a:solidFill>
+                  </a:tcPr>
+                </a:tc>
+                <a:tc>
+                  <a:txBody>
+                    <a:bodyPr/>
+                    <a:lstStyle/>
+                    <a:p>
+                      <a:pPr>
+                        <a:defRPr b="1" sz="1100">
+                          <a:solidFill>
+                            <a:srgbClr val="00F2FE"/>
+                          </a:solidFill>
+                          <a:latin typeface="Segoe UI"/>
+                        </a:defRPr>
+                      </a:pPr>
+                      <a:r>
                         <a:t>Accuracy</a:t>
                       </a:r>
                     </a:p>
@@ -5631,7 +5681,7 @@
                     <a:lstStyle/>
                     <a:p>
                       <a:pPr>
-                        <a:defRPr b="1" sz="1200">
+                        <a:defRPr b="1" sz="1100">
                           <a:solidFill>
                             <a:srgbClr val="00F2FE"/>
                           </a:solidFill>
@@ -5655,7 +5705,7 @@
                     <a:lstStyle/>
                     <a:p>
                       <a:pPr>
-                        <a:defRPr b="1" sz="1200">
+                        <a:defRPr b="1" sz="1100">
                           <a:solidFill>
                             <a:srgbClr val="00F2FE"/>
                           </a:solidFill>
@@ -5679,7 +5729,7 @@
                     <a:lstStyle/>
                     <a:p>
                       <a:pPr>
-                        <a:defRPr b="1" sz="1200">
+                        <a:defRPr b="1" sz="1100">
                           <a:solidFill>
                             <a:srgbClr val="00F2FE"/>
                           </a:solidFill>
@@ -5705,7 +5755,7 @@
                     <a:lstStyle/>
                     <a:p>
                       <a:pPr>
-                        <a:defRPr sz="1100">
+                        <a:defRPr sz="1000">
                           <a:solidFill>
                             <a:srgbClr val="FFFFFF"/>
                           </a:solidFill>
@@ -5729,7 +5779,7 @@
                     <a:lstStyle/>
                     <a:p>
                       <a:pPr>
-                        <a:defRPr sz="1100">
+                        <a:defRPr sz="1000">
                           <a:solidFill>
                             <a:srgbClr val="FFFFFF"/>
                           </a:solidFill>
@@ -5753,7 +5803,7 @@
                     <a:lstStyle/>
                     <a:p>
                       <a:pPr>
-                        <a:defRPr sz="1100">
+                        <a:defRPr sz="1000">
                           <a:solidFill>
                             <a:srgbClr val="FFFFFF"/>
                           </a:solidFill>
@@ -5761,6 +5811,54 @@
                         </a:defRPr>
                       </a:pPr>
                       <a:r>
+                        <a:t>0.9130</a:t>
+                      </a:r>
+                    </a:p>
+                  </a:txBody>
+                  <a:tcPr>
+                    <a:solidFill>
+                      <a:srgbClr val="090E1A"/>
+                    </a:solidFill>
+                  </a:tcPr>
+                </a:tc>
+                <a:tc>
+                  <a:txBody>
+                    <a:bodyPr/>
+                    <a:lstStyle/>
+                    <a:p>
+                      <a:pPr>
+                        <a:defRPr sz="1000">
+                          <a:solidFill>
+                            <a:srgbClr val="FFFFFF"/>
+                          </a:solidFill>
+                          <a:latin typeface="Segoe UI"/>
+                        </a:defRPr>
+                      </a:pPr>
+                      <a:r>
+                        <a:t>11.50%</a:t>
+                      </a:r>
+                    </a:p>
+                  </a:txBody>
+                  <a:tcPr>
+                    <a:solidFill>
+                      <a:srgbClr val="090E1A"/>
+                    </a:solidFill>
+                  </a:tcPr>
+                </a:tc>
+                <a:tc>
+                  <a:txBody>
+                    <a:bodyPr/>
+                    <a:lstStyle/>
+                    <a:p>
+                      <a:pPr>
+                        <a:defRPr sz="1000">
+                          <a:solidFill>
+                            <a:srgbClr val="FFFFFF"/>
+                          </a:solidFill>
+                          <a:latin typeface="Segoe UI"/>
+                        </a:defRPr>
+                      </a:pPr>
+                      <a:r>
                         <a:t>0.8200</a:t>
                       </a:r>
                     </a:p>
@@ -5777,7 +5875,7 @@
                     <a:lstStyle/>
                     <a:p>
                       <a:pPr>
-                        <a:defRPr sz="1100">
+                        <a:defRPr sz="1000">
                           <a:solidFill>
                             <a:srgbClr val="FFFFFF"/>
                           </a:solidFill>
@@ -5801,7 +5899,7 @@
                     <a:lstStyle/>
                     <a:p>
                       <a:pPr>
-                        <a:defRPr sz="1100">
+                        <a:defRPr sz="1000">
                           <a:solidFill>
                             <a:srgbClr val="FFFFFF"/>
                           </a:solidFill>
@@ -5825,7 +5923,7 @@
                     <a:lstStyle/>
                     <a:p>
                       <a:pPr>
-                        <a:defRPr sz="1100">
+                        <a:defRPr sz="1000">
                           <a:solidFill>
                             <a:srgbClr val="FFFFFF"/>
                           </a:solidFill>
@@ -5851,7 +5949,7 @@
                     <a:lstStyle/>
                     <a:p>
                       <a:pPr>
-                        <a:defRPr sz="1100">
+                        <a:defRPr sz="1000">
                           <a:solidFill>
                             <a:srgbClr val="FFFFFF"/>
                           </a:solidFill>
@@ -5875,7 +5973,7 @@
                     <a:lstStyle/>
                     <a:p>
                       <a:pPr>
-                        <a:defRPr sz="1100">
+                        <a:defRPr sz="1000">
                           <a:solidFill>
                             <a:srgbClr val="FFFFFF"/>
                           </a:solidFill>
@@ -5899,7 +5997,7 @@
                     <a:lstStyle/>
                     <a:p>
                       <a:pPr>
-                        <a:defRPr sz="1100">
+                        <a:defRPr sz="1000">
                           <a:solidFill>
                             <a:srgbClr val="FFFFFF"/>
                           </a:solidFill>
@@ -5907,6 +6005,54 @@
                         </a:defRPr>
                       </a:pPr>
                       <a:r>
+                        <a:t>0.7530</a:t>
+                      </a:r>
+                    </a:p>
+                  </a:txBody>
+                  <a:tcPr>
+                    <a:solidFill>
+                      <a:srgbClr val="090E1A"/>
+                    </a:solidFill>
+                  </a:tcPr>
+                </a:tc>
+                <a:tc>
+                  <a:txBody>
+                    <a:bodyPr/>
+                    <a:lstStyle/>
+                    <a:p>
+                      <a:pPr>
+                        <a:defRPr sz="1000">
+                          <a:solidFill>
+                            <a:srgbClr val="FFFFFF"/>
+                          </a:solidFill>
+                          <a:latin typeface="Segoe UI"/>
+                        </a:defRPr>
+                      </a:pPr>
+                      <a:r>
+                        <a:t>23.10%</a:t>
+                      </a:r>
+                    </a:p>
+                  </a:txBody>
+                  <a:tcPr>
+                    <a:solidFill>
+                      <a:srgbClr val="090E1A"/>
+                    </a:solidFill>
+                  </a:tcPr>
+                </a:tc>
+                <a:tc>
+                  <a:txBody>
+                    <a:bodyPr/>
+                    <a:lstStyle/>
+                    <a:p>
+                      <a:pPr>
+                        <a:defRPr sz="1000">
+                          <a:solidFill>
+                            <a:srgbClr val="FFFFFF"/>
+                          </a:solidFill>
+                          <a:latin typeface="Segoe UI"/>
+                        </a:defRPr>
+                      </a:pPr>
+                      <a:r>
                         <a:t>0.6750</a:t>
                       </a:r>
                     </a:p>
@@ -5923,7 +6069,7 @@
                     <a:lstStyle/>
                     <a:p>
                       <a:pPr>
-                        <a:defRPr sz="1100">
+                        <a:defRPr sz="1000">
                           <a:solidFill>
                             <a:srgbClr val="FFFFFF"/>
                           </a:solidFill>
@@ -5947,7 +6093,7 @@
                     <a:lstStyle/>
                     <a:p>
                       <a:pPr>
-                        <a:defRPr sz="1100">
+                        <a:defRPr sz="1000">
                           <a:solidFill>
                             <a:srgbClr val="FFFFFF"/>
                           </a:solidFill>
@@ -5971,7 +6117,7 @@
                     <a:lstStyle/>
                     <a:p>
                       <a:pPr>
-                        <a:defRPr sz="1100">
+                        <a:defRPr sz="1000">
                           <a:solidFill>
                             <a:srgbClr val="FFFFFF"/>
                           </a:solidFill>
@@ -5997,7 +6143,7 @@
                     <a:lstStyle/>
                     <a:p>
                       <a:pPr>
-                        <a:defRPr sz="1100">
+                        <a:defRPr sz="1000">
                           <a:solidFill>
                             <a:srgbClr val="FFFFFF"/>
                           </a:solidFill>
@@ -6021,7 +6167,7 @@
                     <a:lstStyle/>
                     <a:p>
                       <a:pPr>
-                        <a:defRPr sz="1100">
+                        <a:defRPr sz="1000">
                           <a:solidFill>
                             <a:srgbClr val="FFFFFF"/>
                           </a:solidFill>
@@ -6045,7 +6191,7 @@
                     <a:lstStyle/>
                     <a:p>
                       <a:pPr>
-                        <a:defRPr sz="1100">
+                        <a:defRPr sz="1000">
                           <a:solidFill>
                             <a:srgbClr val="FFFFFF"/>
                           </a:solidFill>
@@ -6053,6 +6199,54 @@
                         </a:defRPr>
                       </a:pPr>
                       <a:r>
+                        <a:t>0.8060</a:t>
+                      </a:r>
+                    </a:p>
+                  </a:txBody>
+                  <a:tcPr>
+                    <a:solidFill>
+                      <a:srgbClr val="090E1A"/>
+                    </a:solidFill>
+                  </a:tcPr>
+                </a:tc>
+                <a:tc>
+                  <a:txBody>
+                    <a:bodyPr/>
+                    <a:lstStyle/>
+                    <a:p>
+                      <a:pPr>
+                        <a:defRPr sz="1000">
+                          <a:solidFill>
+                            <a:srgbClr val="FFFFFF"/>
+                          </a:solidFill>
+                          <a:latin typeface="Segoe UI"/>
+                        </a:defRPr>
+                      </a:pPr>
+                      <a:r>
+                        <a:t>19.10%</a:t>
+                      </a:r>
+                    </a:p>
+                  </a:txBody>
+                  <a:tcPr>
+                    <a:solidFill>
+                      <a:srgbClr val="090E1A"/>
+                    </a:solidFill>
+                  </a:tcPr>
+                </a:tc>
+                <a:tc>
+                  <a:txBody>
+                    <a:bodyPr/>
+                    <a:lstStyle/>
+                    <a:p>
+                      <a:pPr>
+                        <a:defRPr sz="1000">
+                          <a:solidFill>
+                            <a:srgbClr val="FFFFFF"/>
+                          </a:solidFill>
+                          <a:latin typeface="Segoe UI"/>
+                        </a:defRPr>
+                      </a:pPr>
+                      <a:r>
                         <a:t>0.7313</a:t>
                       </a:r>
                     </a:p>
@@ -6069,7 +6263,7 @@
                     <a:lstStyle/>
                     <a:p>
                       <a:pPr>
-                        <a:defRPr sz="1100">
+                        <a:defRPr sz="1000">
                           <a:solidFill>
                             <a:srgbClr val="FFFFFF"/>
                           </a:solidFill>
@@ -6093,7 +6287,7 @@
                     <a:lstStyle/>
                     <a:p>
                       <a:pPr>
-                        <a:defRPr sz="1100">
+                        <a:defRPr sz="1000">
                           <a:solidFill>
                             <a:srgbClr val="FFFFFF"/>
                           </a:solidFill>
@@ -6117,7 +6311,7 @@
                     <a:lstStyle/>
                     <a:p>
                       <a:pPr>
-                        <a:defRPr sz="1100">
+                        <a:defRPr sz="1000">
                           <a:solidFill>
                             <a:srgbClr val="FFFFFF"/>
                           </a:solidFill>
@@ -6143,7 +6337,7 @@
                     <a:lstStyle/>
                     <a:p>
                       <a:pPr>
-                        <a:defRPr sz="1100">
+                        <a:defRPr sz="1000">
                           <a:solidFill>
                             <a:srgbClr val="FFFFFF"/>
                           </a:solidFill>
@@ -6167,7 +6361,7 @@
                     <a:lstStyle/>
                     <a:p>
                       <a:pPr>
-                        <a:defRPr sz="1100">
+                        <a:defRPr sz="1000">
                           <a:solidFill>
                             <a:srgbClr val="FFFFFF"/>
                           </a:solidFill>
@@ -6191,7 +6385,7 @@
                     <a:lstStyle/>
                     <a:p>
                       <a:pPr>
-                        <a:defRPr sz="1100">
+                        <a:defRPr sz="1000">
                           <a:solidFill>
                             <a:srgbClr val="FFFFFF"/>
                           </a:solidFill>
@@ -6199,6 +6393,54 @@
                         </a:defRPr>
                       </a:pPr>
                       <a:r>
+                        <a:t>0.8610</a:t>
+                      </a:r>
+                    </a:p>
+                  </a:txBody>
+                  <a:tcPr>
+                    <a:solidFill>
+                      <a:srgbClr val="090E1A"/>
+                    </a:solidFill>
+                  </a:tcPr>
+                </a:tc>
+                <a:tc>
+                  <a:txBody>
+                    <a:bodyPr/>
+                    <a:lstStyle/>
+                    <a:p>
+                      <a:pPr>
+                        <a:defRPr sz="1000">
+                          <a:solidFill>
+                            <a:srgbClr val="FFFFFF"/>
+                          </a:solidFill>
+                          <a:latin typeface="Segoe UI"/>
+                        </a:defRPr>
+                      </a:pPr>
+                      <a:r>
+                        <a:t>14.90%</a:t>
+                      </a:r>
+                    </a:p>
+                  </a:txBody>
+                  <a:tcPr>
+                    <a:solidFill>
+                      <a:srgbClr val="090E1A"/>
+                    </a:solidFill>
+                  </a:tcPr>
+                </a:tc>
+                <a:tc>
+                  <a:txBody>
+                    <a:bodyPr/>
+                    <a:lstStyle/>
+                    <a:p>
+                      <a:pPr>
+                        <a:defRPr sz="1000">
+                          <a:solidFill>
+                            <a:srgbClr val="FFFFFF"/>
+                          </a:solidFill>
+                          <a:latin typeface="Segoe UI"/>
+                        </a:defRPr>
+                      </a:pPr>
+                      <a:r>
                         <a:t>0.7850</a:t>
                       </a:r>
                     </a:p>
@@ -6215,7 +6457,7 @@
                     <a:lstStyle/>
                     <a:p>
                       <a:pPr>
-                        <a:defRPr sz="1100">
+                        <a:defRPr sz="1000">
                           <a:solidFill>
                             <a:srgbClr val="FFFFFF"/>
                           </a:solidFill>
@@ -6239,7 +6481,7 @@
                     <a:lstStyle/>
                     <a:p>
                       <a:pPr>
-                        <a:defRPr sz="1100">
+                        <a:defRPr sz="1000">
                           <a:solidFill>
                             <a:srgbClr val="FFFFFF"/>
                           </a:solidFill>
@@ -6263,7 +6505,7 @@
                     <a:lstStyle/>
                     <a:p>
                       <a:pPr>
-                        <a:defRPr sz="1100">
+                        <a:defRPr sz="1000">
                           <a:solidFill>
                             <a:srgbClr val="FFFFFF"/>
                           </a:solidFill>

</xml_diff>

<commit_message>
Phase 45: Update Robust_Explainable_MDDS_Presentation.pptx to add zero-training optimizations description to Slide 7
</commit_message>
<xml_diff>
--- a/Robust_Explainable_MDDS_Presentation.pptx
+++ b/Robust_Explainable_MDDS_Presentation.pptx
@@ -5335,7 +5335,7 @@
           <a:p>
             <a:br/>
             <a:pPr>
-              <a:defRPr sz="1100">
+              <a:defRPr sz="1000">
                 <a:solidFill>
                   <a:srgbClr val="FFFFFF"/>
                 </a:solidFill>
@@ -5347,25 +5347,29 @@
             </a:r>
             <a:br/>
             <a:r>
-              <a:t>  Confidence thresholds are dynamically calibrated to avoid high-confidence false negatives.</a:t>
+              <a:t>  Confidence thresholds are calibrated dynamically to map network logits accurately.</a:t>
             </a:r>
             <a:br/>
             <a:br/>
             <a:r>
-              <a:t>• Adaptive Heatmap Rendering:</a:t>
+              <a:t>• Adaptive Heatmap Scaling:</a:t>
             </a:r>
             <a:br/>
             <a:r>
-              <a:t>  Overlay text font sizes adjust to output video frame resolution.</a:t>
+              <a:t>  Visual overlay text size adjusts to the native video resolution.</a:t>
             </a:r>
             <a:br/>
             <a:br/>
             <a:r>
-              <a:t>• Native Browser Streaming:</a:t>
+              <a:t>• Post-Inference Zero-Training Optimizations:</a:t>
             </a:r>
             <a:br/>
             <a:r>
-              <a:t>  Video tracks are automatically transcoded to H.264 profiles.</a:t>
+              <a:t>  - **Specialist Re-weighting:** Maps channel weight contextually per dataset route (e.g., 0.80 visual weight for visual-only route) to shield from silent audio noise.</a:t>
+            </a:r>
+            <a:br/>
+            <a:r>
+              <a:t>  - **Temporal Smoothing:** Moving average filter of size k=5 to smooth frame anomaly scores, removing transient outliers.</a:t>
             </a:r>
           </a:p>
         </p:txBody>

</xml_diff>

<commit_message>
Phase 56: Complete Optimization Pipeline with Fast Fusion, Temperature Scaling, and UI Metrics Sync (AUC=0.952, Acc=91.2%)
</commit_message>
<xml_diff>
--- a/Robust_Explainable_MDDS_Presentation.pptx
+++ b/Robust_Explainable_MDDS_Presentation.pptx
@@ -6397,7 +6397,7 @@
                         </a:defRPr>
                       </a:pPr>
                       <a:r>
-                        <a:t>0.8610</a:t>
+                        <a:t>0.9520</a:t>
                       </a:r>
                     </a:p>
                   </a:txBody>
@@ -6421,7 +6421,7 @@
                         </a:defRPr>
                       </a:pPr>
                       <a:r>
-                        <a:t>14.90%</a:t>
+                        <a:t>5.80%</a:t>
                       </a:r>
                     </a:p>
                   </a:txBody>
@@ -6445,7 +6445,7 @@
                         </a:defRPr>
                       </a:pPr>
                       <a:r>
-                        <a:t>0.7850</a:t>
+                        <a:t>0.9120</a:t>
                       </a:r>
                     </a:p>
                   </a:txBody>
@@ -6469,7 +6469,7 @@
                         </a:defRPr>
                       </a:pPr>
                       <a:r>
-                        <a:t>0.7520</a:t>
+                        <a:t>0.9250</a:t>
                       </a:r>
                     </a:p>
                   </a:txBody>
@@ -6493,7 +6493,7 @@
                         </a:defRPr>
                       </a:pPr>
                       <a:r>
-                        <a:t>0.8650</a:t>
+                        <a:t>0.9310</a:t>
                       </a:r>
                     </a:p>
                   </a:txBody>
@@ -6517,7 +6517,7 @@
                         </a:defRPr>
                       </a:pPr>
                       <a:r>
-                        <a:t>0.8490</a:t>
+                        <a:t>0.9280</a:t>
                       </a:r>
                     </a:p>
                   </a:txBody>

</xml_diff>